<commit_message>
fix: tighten custom attention paper figure crops
</commit_message>
<xml_diff>
--- a/01_ai_infra/kernel/custom_attn/多模态稀疏Attention与定制Mask_Kernel调研.pptx
+++ b/01_ai_infra/kernel/custom_attn/多模态稀疏Attention与定制Mask_Kernel调研.pptx
@@ -3756,8 +3756,8 @@
         </p:blipFill>
         <p:spPr>
           <a:xfrm>
-            <a:off x="502920" y="1389017"/>
-            <a:ext cx="6812280" cy="4217125"/>
+            <a:off x="502920" y="1944380"/>
+            <a:ext cx="6812280" cy="3106399"/>
           </a:xfrm>
           <a:prstGeom prst="rect">
             <a:avLst/>
@@ -4471,8 +4471,8 @@
         </p:blipFill>
         <p:spPr>
           <a:xfrm>
-            <a:off x="502920" y="1368742"/>
-            <a:ext cx="6812280" cy="4257675"/>
+            <a:off x="502920" y="2078355"/>
+            <a:ext cx="6812280" cy="2838450"/>
           </a:xfrm>
           <a:prstGeom prst="rect">
             <a:avLst/>
@@ -5186,8 +5186,8 @@
         </p:blipFill>
         <p:spPr>
           <a:xfrm>
-            <a:off x="502920" y="1342132"/>
-            <a:ext cx="6812280" cy="4310895"/>
+            <a:off x="502920" y="1652587"/>
+            <a:ext cx="6812280" cy="3689985"/>
           </a:xfrm>
           <a:prstGeom prst="rect">
             <a:avLst/>
@@ -5901,8 +5901,8 @@
         </p:blipFill>
         <p:spPr>
           <a:xfrm>
-            <a:off x="502920" y="1421963"/>
-            <a:ext cx="6812280" cy="4151233"/>
+            <a:off x="502920" y="1405620"/>
+            <a:ext cx="6812280" cy="4183920"/>
           </a:xfrm>
           <a:prstGeom prst="rect">
             <a:avLst/>
@@ -6616,8 +6616,8 @@
         </p:blipFill>
         <p:spPr>
           <a:xfrm>
-            <a:off x="502920" y="1277516"/>
-            <a:ext cx="5440679" cy="3315414"/>
+            <a:off x="502920" y="1632688"/>
+            <a:ext cx="5440680" cy="2605071"/>
           </a:xfrm>
           <a:prstGeom prst="rect">
             <a:avLst/>
@@ -6671,7 +6671,7 @@
       </p:sp>
       <p:pic>
         <p:nvPicPr>
-          <p:cNvPr id="7" name="Picture 6" descr="table1_fig4_scaling_caption.png"/>
+          <p:cNvPr id="7" name="Picture 6" descr="fig4_wall_time_scaling_caption.png"/>
           <p:cNvPicPr>
             <a:picLocks noChangeAspect="1"/>
           </p:cNvPicPr>
@@ -6685,8 +6685,8 @@
         </p:blipFill>
         <p:spPr>
           <a:xfrm>
-            <a:off x="7170010" y="1234440"/>
-            <a:ext cx="3573075" cy="3401568"/>
+            <a:off x="6236208" y="1780794"/>
+            <a:ext cx="5440680" cy="2308860"/>
           </a:xfrm>
           <a:prstGeom prst="rect">
             <a:avLst/>
@@ -6701,8 +6701,8 @@
         </p:nvSpPr>
         <p:spPr>
           <a:xfrm>
-            <a:off x="640080" y="4892040"/>
-            <a:ext cx="5074920" cy="777240"/>
+            <a:off x="640080" y="4828032"/>
+            <a:ext cx="5074920" cy="932688"/>
           </a:xfrm>
           <a:prstGeom prst="roundRect">
             <a:avLst/>
@@ -6746,8 +6746,8 @@
         </p:nvSpPr>
         <p:spPr>
           <a:xfrm>
-            <a:off x="640080" y="4892040"/>
-            <a:ext cx="91440" cy="777240"/>
+            <a:off x="640080" y="4828032"/>
+            <a:ext cx="91440" cy="932688"/>
           </a:xfrm>
           <a:prstGeom prst="rect">
             <a:avLst/>
@@ -6791,7 +6791,7 @@
         </p:nvSpPr>
         <p:spPr>
           <a:xfrm>
-            <a:off x="841247" y="5020055"/>
+            <a:off x="841247" y="4956048"/>
             <a:ext cx="4764024" cy="237744"/>
           </a:xfrm>
           <a:prstGeom prst="rect">
@@ -6826,8 +6826,8 @@
         </p:nvSpPr>
         <p:spPr>
           <a:xfrm>
-            <a:off x="841247" y="5330952"/>
-            <a:ext cx="4764024" cy="246888"/>
+            <a:off x="841247" y="5266944"/>
+            <a:ext cx="4764024" cy="402336"/>
           </a:xfrm>
           <a:prstGeom prst="rect">
             <a:avLst/>
@@ -6861,8 +6861,8 @@
         </p:nvSpPr>
         <p:spPr>
           <a:xfrm>
-            <a:off x="6400800" y="4892040"/>
-            <a:ext cx="5074920" cy="777240"/>
+            <a:off x="6400800" y="4828032"/>
+            <a:ext cx="5074920" cy="932688"/>
           </a:xfrm>
           <a:prstGeom prst="roundRect">
             <a:avLst/>
@@ -6906,8 +6906,8 @@
         </p:nvSpPr>
         <p:spPr>
           <a:xfrm>
-            <a:off x="6400800" y="4892040"/>
-            <a:ext cx="91440" cy="777240"/>
+            <a:off x="6400800" y="4828032"/>
+            <a:ext cx="91440" cy="932688"/>
           </a:xfrm>
           <a:prstGeom prst="rect">
             <a:avLst/>
@@ -6951,7 +6951,7 @@
         </p:nvSpPr>
         <p:spPr>
           <a:xfrm>
-            <a:off x="6601968" y="5020055"/>
+            <a:off x="6601968" y="4956048"/>
             <a:ext cx="4764024" cy="237744"/>
           </a:xfrm>
           <a:prstGeom prst="rect">
@@ -6986,8 +6986,8 @@
         </p:nvSpPr>
         <p:spPr>
           <a:xfrm>
-            <a:off x="6601968" y="5330952"/>
-            <a:ext cx="4764024" cy="246888"/>
+            <a:off x="6601968" y="5266944"/>
+            <a:ext cx="4764024" cy="402336"/>
           </a:xfrm>
           <a:prstGeom prst="rect">
             <a:avLst/>
@@ -7043,7 +7043,7 @@
                 </a:solidFill>
                 <a:latin typeface="Aptos"/>
               </a:rPr>
-              <a:t>Causal-rCM Fig.4; LVSA Table 1 + Fig.4</a:t>
+              <a:t>Causal-rCM Fig.4; LVSA Fig.4</a:t>
             </a:r>
           </a:p>
         </p:txBody>
@@ -13311,8 +13311,8 @@
         </p:blipFill>
         <p:spPr>
           <a:xfrm>
-            <a:off x="502920" y="1447588"/>
-            <a:ext cx="6812280" cy="4099983"/>
+            <a:off x="502920" y="1340358"/>
+            <a:ext cx="6812280" cy="4314444"/>
           </a:xfrm>
           <a:prstGeom prst="rect">
             <a:avLst/>
@@ -14741,8 +14741,8 @@
         </p:blipFill>
         <p:spPr>
           <a:xfrm>
-            <a:off x="690371" y="1234440"/>
-            <a:ext cx="6437376" cy="4526280"/>
+            <a:off x="502920" y="2011001"/>
+            <a:ext cx="6812280" cy="2973156"/>
           </a:xfrm>
           <a:prstGeom prst="rect">
             <a:avLst/>
@@ -15456,8 +15456,8 @@
         </p:blipFill>
         <p:spPr>
           <a:xfrm>
-            <a:off x="1383234" y="1234440"/>
-            <a:ext cx="5051651" cy="4526280"/>
+            <a:off x="873789" y="1234440"/>
+            <a:ext cx="6070540" cy="4526280"/>
           </a:xfrm>
           <a:prstGeom prst="rect">
             <a:avLst/>
@@ -16171,8 +16171,8 @@
         </p:blipFill>
         <p:spPr>
           <a:xfrm>
-            <a:off x="502920" y="1419257"/>
-            <a:ext cx="6812280" cy="4156645"/>
+            <a:off x="502920" y="1419834"/>
+            <a:ext cx="6812280" cy="4155490"/>
           </a:xfrm>
           <a:prstGeom prst="rect">
             <a:avLst/>
@@ -16886,8 +16886,8 @@
         </p:blipFill>
         <p:spPr>
           <a:xfrm>
-            <a:off x="502920" y="1355008"/>
-            <a:ext cx="6812280" cy="4285143"/>
+            <a:off x="502920" y="1530240"/>
+            <a:ext cx="6812280" cy="3934678"/>
           </a:xfrm>
           <a:prstGeom prst="rect">
             <a:avLst/>

</xml_diff>